<commit_message>
Laboratorio: testi delle slide aggiornati, senza numero di pagina e senza quadratini; video e PowerPoint rifatti
Co-Authored-By: Claude Opus 5.5 <noreply@anthropic.com>
Claude-Session: https://claude.ai/code/session_01LdUZVoKfYuMV2hAhBE7cjt
</commit_message>
<xml_diff>
--- a/presentazioni/2-forza4-claude.pptx
+++ b/presentazioni/2-forza4-claude.pptx
@@ -119,14 +119,14 @@
   <p:extLst>
     <p:ext uri="{521415D9-36F7-43E2-AB2F-B90AF26B5E84}">
       <p14:sectionLst xmlns:p14="http://schemas.microsoft.com/office/powerpoint/2010/main">
-        <p14:section name="Introduzione" id="{1727ad53-5f10-0462-2c76-b49bd0c82213}">
+        <p14:section name="Introduzione" id="{5a48619f-95b1-56a3-014b-0b9de8a8d339}">
           <p14:sldIdLst>
             <p14:sldId id="256"/>
             <p14:sldId id="257"/>
             <p14:sldId id="258"/>
           </p14:sldIdLst>
         </p14:section>
-        <p14:section name="Passo dopo passo" id="{9aac03bb-5ce6-a55f-1249-d950e4725434}">
+        <p14:section name="Passo dopo passo" id="{53a7c656-23fc-d072-3ca7-342adba997be}">
           <p14:sldIdLst>
             <p14:sldId id="259"/>
             <p14:sldId id="260"/>
@@ -138,7 +138,7 @@
             <p14:sldId id="266"/>
           </p14:sldIdLst>
         </p14:section>
-        <p14:section name="Conclusione" id="{94282f78-42c9-36fb-689d-4ab23ce37ee9}">
+        <p14:section name="Conclusione" id="{736b23f7-3c40-0bdc-0466-c61b287a3fcd}">
           <p14:sldIdLst>
             <p14:sldId id="267"/>
             <p14:sldId id="268"/>
@@ -548,8 +548,8 @@
           <a:p>
             <a:r>
               <a:rPr lang="en-US" dirty="0"/>
-              <a:t>Tutorial – Crea e gioca a Forza 4 con Claude
-In meno di 15 minuti crei il tuo videogioco con quattro richieste a Claude e lo giochi subito.
+              <a:t>Tutorial – Crea un gioco con l’AI
+In meno di 15 minuti crei il tuo videogioco con quattro richieste a Claude (o ChatGPT, ecc.) e gioca subito.
 • 4 prompt per costruire il gioco
 • una partita completa contro il computer
 • tempo totale: circa 9 minuti</a:t>
@@ -640,7 +640,7 @@
           <a:p>
             <a:r>
               <a:rPr lang="en-US" dirty="0"/>
-              <a:t>Passo 6 · gioca – Livello Facile e gettoni al centro
+              <a:t>Passo 6 · gioca – Prova subito il tuo gioco!
 Scegli Contro il computer e il livello Facile. Metti il primo gettone al centro (colonna 4), poi accanto: colonne 3 e 5.</a:t>
             </a:r>
             <a:endParaRPr lang="en-US" dirty="0"/>
@@ -729,7 +729,7 @@
           <a:p>
             <a:r>
               <a:rPr lang="en-US" dirty="0"/>
-              <a:t>Passo 7 · la trappola – Tre in fila con due lati liberi
+              <a:t>Passo 7 · la trappola – Ricorda le regole…
 Con tre gettoni in fila e entrambi i lati liberi, il computer può bloccarne uno solo. Tu chiudi l’altro: qui la colonna 6.</a:t>
             </a:r>
             <a:endParaRPr lang="en-US" dirty="0"/>
@@ -1269,7 +1269,7 @@
               <a:rPr lang="en-US" dirty="0"/>
               <a:t>Passo 2 · primo prompt – Chiedi a Claude di creare il gioco
 Scrivi con calma, rileggi e premi invio. Claude scrive il codice: mentre lavora vedi l’avanzamento.
-Prompt da scrivere: Creami un gioco di Forza 4 da giocare nel browser: griglia 7x6, gettoni rossi e gialli, contro il computer oppure in due giocatori.
+Prompt da scrivere: Creami un gioco come Forza 4 da giocare nel browser: griglia 7x6, gettoni rossi e gialli, contro il computer oppure in due giocatori.
 Tempo: Claude ci mette circa 1:30</a:t>
             </a:r>
             <a:endParaRPr lang="en-US" dirty="0"/>
@@ -1629,7 +1629,7 @@
           <a:p>
             <a:r>
               <a:rPr lang="en-US" dirty="0"/>
-              <a:t>Passo 5 · quarto prompt – Festa quando vinci
+              <a:t>Passo 5 · quarto prompt – Scatena un evento
 Il gioco è completo. Sono passati circa 9 minuti: ne restano 6 per giocare.
 Prompt da scrivere: Quando vinco fai partire i fuochi d'artificio. Quando vince il computer, fai esplodere i gettoni fuori dallo schermo!
 Tempo: Claude ci mette circa 1:15</a:t>
@@ -2890,7 +2890,7 @@
       </p:grpSpPr>
       <p:pic>
         <p:nvPicPr>
-          <p:cNvPr id="2" name="Immagine" descr="Crea e gioca a Forza 4 con Claude">    </p:cNvPr>
+          <p:cNvPr id="2" name="Immagine" descr="Crea un gioco con l’AI">    </p:cNvPr>
           <p:cNvPicPr>
             <a:picLocks noChangeAspect="1"/>
           </p:cNvPicPr>
@@ -3020,7 +3020,7 @@
                   <a:schemeClr val="bg1"/>
                 </a:solidFill>
               </a:rPr>
-              <a:t>Crea e gioca a Forza 4 con Claude</a:t>
+              <a:t>Crea un gioco con l’AI</a:t>
             </a:r>
             <a:endParaRPr lang="en-US" sz="2800" dirty="0"/>
           </a:p>
@@ -3077,7 +3077,7 @@
                   <a:schemeClr val="bg2"/>
                 </a:solidFill>
               </a:rPr>
-              <a:t> crei il tuo videogioco con quattro richieste a Claude e lo giochi subito.</a:t>
+              <a:t> crei il tuo videogioco con quattro richieste a Claude (o ChatGPT, ecc.) e gioca subito.</a:t>
             </a:r>
             <a:endParaRPr lang="en-US" sz="1500" dirty="0"/>
           </a:p>
@@ -3209,7 +3209,7 @@
       </p:grpSpPr>
       <p:pic>
         <p:nvPicPr>
-          <p:cNvPr id="2" name="Immagine" descr="Livello Facile e gettoni al centro">    </p:cNvPr>
+          <p:cNvPr id="2" name="Immagine" descr="Prova subito il tuo gioco!">    </p:cNvPr>
           <p:cNvPicPr>
             <a:picLocks noChangeAspect="1"/>
           </p:cNvPicPr>
@@ -3339,7 +3339,7 @@
                   <a:schemeClr val="bg1"/>
                 </a:solidFill>
               </a:rPr>
-              <a:t>Livello Facile e gettoni al centro</a:t>
+              <a:t>Prova subito il tuo gioco!</a:t>
             </a:r>
             <a:endParaRPr lang="en-US" sz="2800" dirty="0"/>
           </a:p>
@@ -3538,7 +3538,7 @@
       </p:grpSpPr>
       <p:pic>
         <p:nvPicPr>
-          <p:cNvPr id="2" name="Immagine" descr="Tre in fila con due lati liberi">    </p:cNvPr>
+          <p:cNvPr id="2" name="Immagine" descr="Ricorda le regole…">    </p:cNvPr>
           <p:cNvPicPr>
             <a:picLocks noChangeAspect="1"/>
           </p:cNvPicPr>
@@ -3668,7 +3668,7 @@
                   <a:schemeClr val="bg1"/>
                 </a:solidFill>
               </a:rPr>
-              <a:t>Tre in fila con due lati liberi</a:t>
+              <a:t>Ricorda le regole…</a:t>
             </a:r>
             <a:endParaRPr lang="en-US" sz="2800" dirty="0"/>
           </a:p>
@@ -5472,7 +5472,7 @@
                   <a:schemeClr val="bg1"/>
                 </a:solidFill>
               </a:rPr>
-              <a:t>“Creami un gioco di Forza 4 da giocare nel browser: griglia 7x6, gettoni rossi e gialli, contro il computer oppure in due giocatori.”</a:t>
+              <a:t>“Creami un gioco come Forza 4 da giocare nel browser: griglia 7x6, gettoni rossi e gialli, contro il computer oppure in due giocatori.”</a:t>
             </a:r>
             <a:endParaRPr lang="en-US" sz="1300" dirty="0"/>
           </a:p>
@@ -6549,7 +6549,7 @@
       </p:grpSpPr>
       <p:pic>
         <p:nvPicPr>
-          <p:cNvPr id="2" name="Immagine" descr="Festa quando vinci">    </p:cNvPr>
+          <p:cNvPr id="2" name="Immagine" descr="Scatena un evento">    </p:cNvPr>
           <p:cNvPicPr>
             <a:picLocks noChangeAspect="1"/>
           </p:cNvPicPr>
@@ -6679,7 +6679,7 @@
                   <a:schemeClr val="bg1"/>
                 </a:solidFill>
               </a:rPr>
-              <a:t>Festa quando vinci</a:t>
+              <a:t>Scatena un evento</a:t>
             </a:r>
             <a:endParaRPr lang="en-US" sz="2800" dirty="0"/>
           </a:p>

</xml_diff>

<commit_message>
Laboratorio: il passo 4 si chiama «Grafica e immagini» (presentazione, tutorial, video e PowerPoint)
Co-Authored-By: Claude Opus 5.5 <noreply@anthropic.com>
Claude-Session: https://claude.ai/code/session_01LdUZVoKfYuMV2hAhBE7cjt
</commit_message>
<xml_diff>
--- a/presentazioni/2-forza4-claude.pptx
+++ b/presentazioni/2-forza4-claude.pptx
@@ -119,14 +119,14 @@
   <p:extLst>
     <p:ext uri="{521415D9-36F7-43E2-AB2F-B90AF26B5E84}">
       <p14:sectionLst xmlns:p14="http://schemas.microsoft.com/office/powerpoint/2010/main">
-        <p14:section name="Introduzione" id="{5a48619f-95b1-56a3-014b-0b9de8a8d339}">
+        <p14:section name="Introduzione" id="{4a0df6e6-58f1-4b63-1014-04874d4cb7d5}">
           <p14:sldIdLst>
             <p14:sldId id="256"/>
             <p14:sldId id="257"/>
             <p14:sldId id="258"/>
           </p14:sldIdLst>
         </p14:section>
-        <p14:section name="Passo dopo passo" id="{53a7c656-23fc-d072-3ca7-342adba997be}">
+        <p14:section name="Passo dopo passo" id="{2be2592e-8b92-e2bd-cd24-0c22c16e36ff}">
           <p14:sldIdLst>
             <p14:sldId id="259"/>
             <p14:sldId id="260"/>
@@ -138,7 +138,7 @@
             <p14:sldId id="266"/>
           </p14:sldIdLst>
         </p14:section>
-        <p14:section name="Conclusione" id="{736b23f7-3c40-0bdc-0466-c61b287a3fcd}">
+        <p14:section name="Conclusione" id="{4b86d14f-9e10-4d6e-46c9-f7ba52bf2f95}">
           <p14:sldIdLst>
             <p14:sldId id="267"/>
             <p14:sldId id="268"/>
@@ -1538,7 +1538,7 @@
           <a:p>
             <a:r>
               <a:rPr lang="en-US" dirty="0"/>
-              <a:t>Passo 4 · terzo prompt – Euro e dollaro sui gettoni
+              <a:t>Passo 4 · terzo prompt – Grafica e immagini
 Le modifiche piccole sono le più veloci: meno di un minuto.
 Prompt da scrivere: Sui gettoni rossi metti il simbolo dell'euro e su quelli gialli il dollaro.
 Tempo: Claude ci mette circa 0:40</a:t>
@@ -6202,7 +6202,7 @@
       </p:grpSpPr>
       <p:pic>
         <p:nvPicPr>
-          <p:cNvPr id="2" name="Immagine" descr="Euro e dollaro sui gettoni">    </p:cNvPr>
+          <p:cNvPr id="2" name="Immagine" descr="Grafica e immagini">    </p:cNvPr>
           <p:cNvPicPr>
             <a:picLocks noChangeAspect="1"/>
           </p:cNvPicPr>
@@ -6332,7 +6332,7 @@
                   <a:schemeClr val="bg1"/>
                 </a:solidFill>
               </a:rPr>
-              <a:t>Euro e dollaro sui gettoni</a:t>
+              <a:t>Grafica e immagini</a:t>
             </a:r>
             <a:endParaRPr lang="en-US" sz="2800" dirty="0"/>
           </a:p>

</xml_diff>